<commit_message>
feat: nova funcionalidade no main module10/studentchalleng refac: refatorei para organização sem mudar a lógica
</commit_message>
<xml_diff>
--- a/src/module10/content/Generics.pptx
+++ b/src/module10/content/Generics.pptx
@@ -19328,7 +19328,7 @@
         </p:nvSpPr>
         <p:spPr>
           <a:xfrm>
-            <a:off x="411480" y="3995928"/>
+            <a:off x="411480" y="3786713"/>
             <a:ext cx="8321040" cy="418429"/>
           </a:xfrm>
           <a:prstGeom prst="rect">
@@ -19378,7 +19378,7 @@
         </p:nvSpPr>
         <p:spPr>
           <a:xfrm>
-            <a:off x="365760" y="4416552"/>
+            <a:off x="365760" y="4207337"/>
             <a:ext cx="8412480" cy="437449"/>
           </a:xfrm>
           <a:prstGeom prst="rect">
@@ -19403,7 +19403,7 @@
         </p:nvSpPr>
         <p:spPr>
           <a:xfrm>
-            <a:off x="502920" y="4453128"/>
+            <a:off x="502920" y="4243913"/>
             <a:ext cx="8229600" cy="418429"/>
           </a:xfrm>
           <a:prstGeom prst="rect">
@@ -19442,7 +19442,7 @@
         </p:nvSpPr>
         <p:spPr>
           <a:xfrm>
-            <a:off x="365760" y="4892040"/>
+            <a:off x="365760" y="4682825"/>
             <a:ext cx="8412480" cy="437449"/>
           </a:xfrm>
           <a:prstGeom prst="rect">
@@ -19467,7 +19467,7 @@
         </p:nvSpPr>
         <p:spPr>
           <a:xfrm>
-            <a:off x="502920" y="4928616"/>
+            <a:off x="502920" y="4719401"/>
             <a:ext cx="8229600" cy="418429"/>
           </a:xfrm>
           <a:prstGeom prst="rect">
@@ -19506,7 +19506,7 @@
         </p:nvSpPr>
         <p:spPr>
           <a:xfrm>
-            <a:off x="365760" y="5367528"/>
+            <a:off x="365760" y="5158313"/>
             <a:ext cx="8412480" cy="437449"/>
           </a:xfrm>
           <a:prstGeom prst="rect">
@@ -19531,7 +19531,7 @@
         </p:nvSpPr>
         <p:spPr>
           <a:xfrm>
-            <a:off x="502920" y="5404104"/>
+            <a:off x="502920" y="5194889"/>
             <a:ext cx="8229600" cy="418429"/>
           </a:xfrm>
           <a:prstGeom prst="rect">
@@ -19570,7 +19570,7 @@
         </p:nvSpPr>
         <p:spPr>
           <a:xfrm>
-            <a:off x="365760" y="5843016"/>
+            <a:off x="365760" y="5633801"/>
             <a:ext cx="8412480" cy="427939"/>
           </a:xfrm>
           <a:prstGeom prst="rect">
@@ -19597,7 +19597,7 @@
         </p:nvSpPr>
         <p:spPr>
           <a:xfrm>
-            <a:off x="548640" y="5879592"/>
+            <a:off x="548640" y="5670377"/>
             <a:ext cx="8046720" cy="404165"/>
           </a:xfrm>
           <a:prstGeom prst="rect">
@@ -19625,70 +19625,6 @@
               <a:t>É prática comum incluir Comparators como classes aninhadas estáticas.</a:t>
             </a:r>
             <a:endParaRPr lang="en-US" sz="1500" dirty="0"/>
-          </a:p>
-        </p:txBody>
-      </p:sp>
-      <p:sp>
-        <p:nvSpPr>
-          <p:cNvPr id="25" name="Shape 23"/>
-          <p:cNvSpPr/>
-          <p:nvPr/>
-        </p:nvSpPr>
-        <p:spPr>
-          <a:xfrm>
-            <a:off x="0" y="4919472"/>
-            <a:ext cx="9144000" cy="224028"/>
-          </a:xfrm>
-          <a:prstGeom prst="rect">
-            <a:avLst/>
-          </a:prstGeom>
-          <a:solidFill>
-            <a:srgbClr val="1A2B4A"/>
-          </a:solidFill>
-          <a:ln w="12700">
-            <a:solidFill>
-              <a:srgbClr val="1A2B4A"/>
-            </a:solidFill>
-            <a:prstDash val="solid"/>
-          </a:ln>
-        </p:spPr>
-      </p:sp>
-      <p:sp>
-        <p:nvSpPr>
-          <p:cNvPr id="26" name="Text 24"/>
-          <p:cNvSpPr/>
-          <p:nvPr/>
-        </p:nvSpPr>
-        <p:spPr>
-          <a:xfrm>
-            <a:off x="274320" y="4937760"/>
-            <a:ext cx="5486400" cy="182880"/>
-          </a:xfrm>
-          <a:prstGeom prst="rect">
-            <a:avLst/>
-          </a:prstGeom>
-          <a:noFill/>
-          <a:ln/>
-        </p:spPr>
-        <p:txBody>
-          <a:bodyPr wrap="square" lIns="0" tIns="0" rIns="0" bIns="0" rtlCol="0" anchor="ctr"/>
-          <a:lstStyle/>
-          <a:p>
-            <a:pPr marL="0" indent="0">
-              <a:buNone/>
-            </a:pPr>
-            <a:r>
-              <a:rPr lang="en-US" sz="900" dirty="0">
-                <a:solidFill>
-                  <a:srgbClr val="CBD5E1"/>
-                </a:solidFill>
-                <a:latin typeface="Calibri" pitchFamily="34" charset="0"/>
-                <a:ea typeface="Calibri" pitchFamily="34" charset="-122"/>
-                <a:cs typeface="Calibri" pitchFamily="34" charset="-120"/>
-              </a:rPr>
-              <a:t>Generics em Java</a:t>
-            </a:r>
-            <a:endParaRPr lang="en-US" sz="900" dirty="0"/>
           </a:p>
         </p:txBody>
       </p:sp>
@@ -20517,70 +20453,6 @@
           </a:p>
         </p:txBody>
       </p:sp>
-      <p:sp>
-        <p:nvSpPr>
-          <p:cNvPr id="14" name="Shape 12"/>
-          <p:cNvSpPr/>
-          <p:nvPr/>
-        </p:nvSpPr>
-        <p:spPr>
-          <a:xfrm>
-            <a:off x="0" y="4919472"/>
-            <a:ext cx="9144000" cy="224028"/>
-          </a:xfrm>
-          <a:prstGeom prst="rect">
-            <a:avLst/>
-          </a:prstGeom>
-          <a:solidFill>
-            <a:srgbClr val="1A2B4A"/>
-          </a:solidFill>
-          <a:ln w="12700">
-            <a:solidFill>
-              <a:srgbClr val="1A2B4A"/>
-            </a:solidFill>
-            <a:prstDash val="solid"/>
-          </a:ln>
-        </p:spPr>
-      </p:sp>
-      <p:sp>
-        <p:nvSpPr>
-          <p:cNvPr id="15" name="Text 13"/>
-          <p:cNvSpPr/>
-          <p:nvPr/>
-        </p:nvSpPr>
-        <p:spPr>
-          <a:xfrm>
-            <a:off x="274320" y="4937760"/>
-            <a:ext cx="5486400" cy="182880"/>
-          </a:xfrm>
-          <a:prstGeom prst="rect">
-            <a:avLst/>
-          </a:prstGeom>
-          <a:noFill/>
-          <a:ln/>
-        </p:spPr>
-        <p:txBody>
-          <a:bodyPr wrap="square" lIns="0" tIns="0" rIns="0" bIns="0" rtlCol="0" anchor="ctr"/>
-          <a:lstStyle/>
-          <a:p>
-            <a:pPr marL="0" indent="0">
-              <a:buNone/>
-            </a:pPr>
-            <a:r>
-              <a:rPr lang="en-US" sz="900" dirty="0">
-                <a:solidFill>
-                  <a:srgbClr val="CBD5E1"/>
-                </a:solidFill>
-                <a:latin typeface="Calibri" pitchFamily="34" charset="0"/>
-                <a:ea typeface="Calibri" pitchFamily="34" charset="-122"/>
-                <a:cs typeface="Calibri" pitchFamily="34" charset="-120"/>
-              </a:rPr>
-              <a:t>Generics em Java</a:t>
-            </a:r>
-            <a:endParaRPr lang="en-US" sz="900" dirty="0"/>
-          </a:p>
-        </p:txBody>
-      </p:sp>
     </p:spTree>
   </p:cSld>
   <p:clrMapOvr>
@@ -21053,198 +20925,6 @@
           </a:p>
         </p:txBody>
       </p:sp>
-      <p:sp>
-        <p:nvSpPr>
-          <p:cNvPr id="12" name="Shape 10"/>
-          <p:cNvSpPr/>
-          <p:nvPr/>
-        </p:nvSpPr>
-        <p:spPr>
-          <a:xfrm>
-            <a:off x="365760" y="4416552"/>
-            <a:ext cx="8412480" cy="437449"/>
-          </a:xfrm>
-          <a:prstGeom prst="rect">
-            <a:avLst/>
-          </a:prstGeom>
-          <a:solidFill>
-            <a:srgbClr val="1E3A5F"/>
-          </a:solidFill>
-          <a:ln w="6350">
-            <a:solidFill>
-              <a:srgbClr val="0D7C8F"/>
-            </a:solidFill>
-            <a:prstDash val="solid"/>
-          </a:ln>
-        </p:spPr>
-      </p:sp>
-      <p:sp>
-        <p:nvSpPr>
-          <p:cNvPr id="13" name="Text 11"/>
-          <p:cNvSpPr/>
-          <p:nvPr/>
-        </p:nvSpPr>
-        <p:spPr>
-          <a:xfrm>
-            <a:off x="502920" y="4453128"/>
-            <a:ext cx="8229600" cy="418429"/>
-          </a:xfrm>
-          <a:prstGeom prst="rect">
-            <a:avLst/>
-          </a:prstGeom>
-          <a:noFill/>
-          <a:ln/>
-        </p:spPr>
-        <p:txBody>
-          <a:bodyPr wrap="square" lIns="0" tIns="0" rIns="0" bIns="0" rtlCol="0" anchor="ctr"/>
-          <a:lstStyle/>
-          <a:p>
-            <a:pPr marL="0" indent="0">
-              <a:buNone/>
-            </a:pPr>
-            <a:r>
-              <a:rPr lang="en-US" sz="1300" dirty="0">
-                <a:solidFill>
-                  <a:srgbClr val="7DD3FC"/>
-                </a:solidFill>
-                <a:latin typeface="Courier New" pitchFamily="34" charset="0"/>
-                <a:ea typeface="Courier New" pitchFamily="34" charset="-122"/>
-                <a:cs typeface="Courier New" pitchFamily="34" charset="-120"/>
-              </a:rPr>
-              <a:t>lista.sort(Comparator.naturalOrder());  // por ID</a:t>
-            </a:r>
-            <a:endParaRPr lang="en-US" sz="1300" dirty="0"/>
-          </a:p>
-        </p:txBody>
-      </p:sp>
-      <p:sp>
-        <p:nvSpPr>
-          <p:cNvPr id="14" name="Shape 12"/>
-          <p:cNvSpPr/>
-          <p:nvPr/>
-        </p:nvSpPr>
-        <p:spPr>
-          <a:xfrm>
-            <a:off x="365760" y="4892040"/>
-            <a:ext cx="8412480" cy="437449"/>
-          </a:xfrm>
-          <a:prstGeom prst="rect">
-            <a:avLst/>
-          </a:prstGeom>
-          <a:solidFill>
-            <a:srgbClr val="1E3A5F"/>
-          </a:solidFill>
-          <a:ln w="6350">
-            <a:solidFill>
-              <a:srgbClr val="0D7C8F"/>
-            </a:solidFill>
-            <a:prstDash val="solid"/>
-          </a:ln>
-        </p:spPr>
-      </p:sp>
-      <p:sp>
-        <p:nvSpPr>
-          <p:cNvPr id="15" name="Text 13"/>
-          <p:cNvSpPr/>
-          <p:nvPr/>
-        </p:nvSpPr>
-        <p:spPr>
-          <a:xfrm>
-            <a:off x="502920" y="4928616"/>
-            <a:ext cx="8229600" cy="418429"/>
-          </a:xfrm>
-          <a:prstGeom prst="rect">
-            <a:avLst/>
-          </a:prstGeom>
-          <a:noFill/>
-          <a:ln/>
-        </p:spPr>
-        <p:txBody>
-          <a:bodyPr wrap="square" lIns="0" tIns="0" rIns="0" bIns="0" rtlCol="0" anchor="ctr"/>
-          <a:lstStyle/>
-          <a:p>
-            <a:pPr marL="0" indent="0">
-              <a:buNone/>
-            </a:pPr>
-            <a:r>
-              <a:rPr lang="en-US" sz="1300" dirty="0">
-                <a:solidFill>
-                  <a:srgbClr val="7DD3FC"/>
-                </a:solidFill>
-                <a:latin typeface="Courier New" pitchFamily="34" charset="0"/>
-                <a:ea typeface="Courier New" pitchFamily="34" charset="-122"/>
-                <a:cs typeface="Courier New" pitchFamily="34" charset="-120"/>
-              </a:rPr>
-              <a:t>lista.sort(Comparator.comparing(Student::getCurso));  // por curso</a:t>
-            </a:r>
-            <a:endParaRPr lang="en-US" sz="1300" dirty="0"/>
-          </a:p>
-        </p:txBody>
-      </p:sp>
-      <p:sp>
-        <p:nvSpPr>
-          <p:cNvPr id="16" name="Shape 14"/>
-          <p:cNvSpPr/>
-          <p:nvPr/>
-        </p:nvSpPr>
-        <p:spPr>
-          <a:xfrm>
-            <a:off x="0" y="4919472"/>
-            <a:ext cx="9144000" cy="224028"/>
-          </a:xfrm>
-          <a:prstGeom prst="rect">
-            <a:avLst/>
-          </a:prstGeom>
-          <a:solidFill>
-            <a:srgbClr val="1A2B4A"/>
-          </a:solidFill>
-          <a:ln w="12700">
-            <a:solidFill>
-              <a:srgbClr val="1A2B4A"/>
-            </a:solidFill>
-            <a:prstDash val="solid"/>
-          </a:ln>
-        </p:spPr>
-      </p:sp>
-      <p:sp>
-        <p:nvSpPr>
-          <p:cNvPr id="17" name="Text 15"/>
-          <p:cNvSpPr/>
-          <p:nvPr/>
-        </p:nvSpPr>
-        <p:spPr>
-          <a:xfrm>
-            <a:off x="274320" y="4937760"/>
-            <a:ext cx="5486400" cy="182880"/>
-          </a:xfrm>
-          <a:prstGeom prst="rect">
-            <a:avLst/>
-          </a:prstGeom>
-          <a:noFill/>
-          <a:ln/>
-        </p:spPr>
-        <p:txBody>
-          <a:bodyPr wrap="square" lIns="0" tIns="0" rIns="0" bIns="0" rtlCol="0" anchor="ctr"/>
-          <a:lstStyle/>
-          <a:p>
-            <a:pPr marL="0" indent="0">
-              <a:buNone/>
-            </a:pPr>
-            <a:r>
-              <a:rPr lang="en-US" sz="900" dirty="0">
-                <a:solidFill>
-                  <a:srgbClr val="CBD5E1"/>
-                </a:solidFill>
-                <a:latin typeface="Calibri" pitchFamily="34" charset="0"/>
-                <a:ea typeface="Calibri" pitchFamily="34" charset="-122"/>
-                <a:cs typeface="Calibri" pitchFamily="34" charset="-120"/>
-              </a:rPr>
-              <a:t>Generics em Java</a:t>
-            </a:r>
-            <a:endParaRPr lang="en-US" sz="900" dirty="0"/>
-          </a:p>
-        </p:txBody>
-      </p:sp>
     </p:spTree>
   </p:cSld>
   <p:clrMapOvr>
@@ -22140,70 +21820,6 @@
           </a:p>
         </p:txBody>
       </p:sp>
-      <p:sp>
-        <p:nvSpPr>
-          <p:cNvPr id="19" name="Shape 17"/>
-          <p:cNvSpPr/>
-          <p:nvPr/>
-        </p:nvSpPr>
-        <p:spPr>
-          <a:xfrm>
-            <a:off x="0" y="4919472"/>
-            <a:ext cx="9144000" cy="224028"/>
-          </a:xfrm>
-          <a:prstGeom prst="rect">
-            <a:avLst/>
-          </a:prstGeom>
-          <a:solidFill>
-            <a:srgbClr val="1A2B4A"/>
-          </a:solidFill>
-          <a:ln w="12700">
-            <a:solidFill>
-              <a:srgbClr val="1A2B4A"/>
-            </a:solidFill>
-            <a:prstDash val="solid"/>
-          </a:ln>
-        </p:spPr>
-      </p:sp>
-      <p:sp>
-        <p:nvSpPr>
-          <p:cNvPr id="20" name="Text 18"/>
-          <p:cNvSpPr/>
-          <p:nvPr/>
-        </p:nvSpPr>
-        <p:spPr>
-          <a:xfrm>
-            <a:off x="274320" y="4937760"/>
-            <a:ext cx="5486400" cy="182880"/>
-          </a:xfrm>
-          <a:prstGeom prst="rect">
-            <a:avLst/>
-          </a:prstGeom>
-          <a:noFill/>
-          <a:ln/>
-        </p:spPr>
-        <p:txBody>
-          <a:bodyPr wrap="square" lIns="0" tIns="0" rIns="0" bIns="0" rtlCol="0" anchor="ctr"/>
-          <a:lstStyle/>
-          <a:p>
-            <a:pPr marL="0" indent="0">
-              <a:buNone/>
-            </a:pPr>
-            <a:r>
-              <a:rPr lang="en-US" sz="900" dirty="0">
-                <a:solidFill>
-                  <a:srgbClr val="CBD5E1"/>
-                </a:solidFill>
-                <a:latin typeface="Calibri" pitchFamily="34" charset="0"/>
-                <a:ea typeface="Calibri" pitchFamily="34" charset="-122"/>
-                <a:cs typeface="Calibri" pitchFamily="34" charset="-120"/>
-              </a:rPr>
-              <a:t>Generics em Java</a:t>
-            </a:r>
-            <a:endParaRPr lang="en-US" sz="900" dirty="0"/>
-          </a:p>
-        </p:txBody>
-      </p:sp>
     </p:spTree>
   </p:cSld>
   <p:clrMapOvr>
@@ -22876,70 +22492,6 @@
           </a:p>
         </p:txBody>
       </p:sp>
-      <p:sp>
-        <p:nvSpPr>
-          <p:cNvPr id="21" name="Shape 19"/>
-          <p:cNvSpPr/>
-          <p:nvPr/>
-        </p:nvSpPr>
-        <p:spPr>
-          <a:xfrm>
-            <a:off x="0" y="4919472"/>
-            <a:ext cx="9144000" cy="224028"/>
-          </a:xfrm>
-          <a:prstGeom prst="rect">
-            <a:avLst/>
-          </a:prstGeom>
-          <a:solidFill>
-            <a:srgbClr val="1A2B4A"/>
-          </a:solidFill>
-          <a:ln w="12700">
-            <a:solidFill>
-              <a:srgbClr val="1A2B4A"/>
-            </a:solidFill>
-            <a:prstDash val="solid"/>
-          </a:ln>
-        </p:spPr>
-      </p:sp>
-      <p:sp>
-        <p:nvSpPr>
-          <p:cNvPr id="22" name="Text 20"/>
-          <p:cNvSpPr/>
-          <p:nvPr/>
-        </p:nvSpPr>
-        <p:spPr>
-          <a:xfrm>
-            <a:off x="274320" y="4937760"/>
-            <a:ext cx="5486400" cy="182880"/>
-          </a:xfrm>
-          <a:prstGeom prst="rect">
-            <a:avLst/>
-          </a:prstGeom>
-          <a:noFill/>
-          <a:ln/>
-        </p:spPr>
-        <p:txBody>
-          <a:bodyPr wrap="square" lIns="0" tIns="0" rIns="0" bIns="0" rtlCol="0" anchor="ctr"/>
-          <a:lstStyle/>
-          <a:p>
-            <a:pPr marL="0" indent="0">
-              <a:buNone/>
-            </a:pPr>
-            <a:r>
-              <a:rPr lang="en-US" sz="900" dirty="0">
-                <a:solidFill>
-                  <a:srgbClr val="CBD5E1"/>
-                </a:solidFill>
-                <a:latin typeface="Calibri" pitchFamily="34" charset="0"/>
-                <a:ea typeface="Calibri" pitchFamily="34" charset="-122"/>
-                <a:cs typeface="Calibri" pitchFamily="34" charset="-120"/>
-              </a:rPr>
-              <a:t>Generics em Java</a:t>
-            </a:r>
-            <a:endParaRPr lang="en-US" sz="900" dirty="0"/>
-          </a:p>
-        </p:txBody>
-      </p:sp>
     </p:spTree>
   </p:cSld>
   <p:clrMapOvr>
@@ -23120,8 +22672,8 @@
         </p:nvSpPr>
         <p:spPr>
           <a:xfrm>
-            <a:off x="365760" y="1563624"/>
-            <a:ext cx="8412480" cy="437449"/>
+            <a:off x="365760" y="1563625"/>
+            <a:ext cx="8412480" cy="231726"/>
           </a:xfrm>
           <a:prstGeom prst="rect">
             <a:avLst/>
@@ -23146,7 +22698,7 @@
         <p:spPr>
           <a:xfrm>
             <a:off x="502920" y="1600200"/>
-            <a:ext cx="8229600" cy="418429"/>
+            <a:ext cx="8229600" cy="221651"/>
           </a:xfrm>
           <a:prstGeom prst="rect">
             <a:avLst/>
@@ -23184,8 +22736,8 @@
         </p:nvSpPr>
         <p:spPr>
           <a:xfrm>
-            <a:off x="365760" y="2039112"/>
-            <a:ext cx="8412480" cy="437449"/>
+            <a:off x="365760" y="2039113"/>
+            <a:ext cx="8412480" cy="231726"/>
           </a:xfrm>
           <a:prstGeom prst="rect">
             <a:avLst/>
@@ -23210,7 +22762,7 @@
         <p:spPr>
           <a:xfrm>
             <a:off x="502920" y="2075688"/>
-            <a:ext cx="8229600" cy="418429"/>
+            <a:ext cx="8229600" cy="221651"/>
           </a:xfrm>
           <a:prstGeom prst="rect">
             <a:avLst/>
@@ -23248,8 +22800,8 @@
         </p:nvSpPr>
         <p:spPr>
           <a:xfrm>
-            <a:off x="365760" y="2514600"/>
-            <a:ext cx="8412480" cy="437449"/>
+            <a:off x="365760" y="2514601"/>
+            <a:ext cx="8412480" cy="231726"/>
           </a:xfrm>
           <a:prstGeom prst="rect">
             <a:avLst/>
@@ -23274,7 +22826,7 @@
         <p:spPr>
           <a:xfrm>
             <a:off x="502920" y="2551176"/>
-            <a:ext cx="8229600" cy="418429"/>
+            <a:ext cx="8229600" cy="221651"/>
           </a:xfrm>
           <a:prstGeom prst="rect">
             <a:avLst/>
@@ -23312,8 +22864,8 @@
         </p:nvSpPr>
         <p:spPr>
           <a:xfrm>
-            <a:off x="365760" y="2990088"/>
-            <a:ext cx="8412480" cy="437449"/>
+            <a:off x="365760" y="2990089"/>
+            <a:ext cx="8412480" cy="231726"/>
           </a:xfrm>
           <a:prstGeom prst="rect">
             <a:avLst/>
@@ -23338,7 +22890,7 @@
         <p:spPr>
           <a:xfrm>
             <a:off x="502920" y="3026664"/>
-            <a:ext cx="8229600" cy="418429"/>
+            <a:ext cx="8229600" cy="221651"/>
           </a:xfrm>
           <a:prstGeom prst="rect">
             <a:avLst/>
@@ -23376,8 +22928,8 @@
         </p:nvSpPr>
         <p:spPr>
           <a:xfrm>
-            <a:off x="411480" y="3520440"/>
-            <a:ext cx="8321040" cy="418429"/>
+            <a:off x="411480" y="3309014"/>
+            <a:ext cx="8321040" cy="221651"/>
           </a:xfrm>
           <a:prstGeom prst="rect">
             <a:avLst/>
@@ -23426,8 +22978,8 @@
         </p:nvSpPr>
         <p:spPr>
           <a:xfrm>
-            <a:off x="365760" y="3941064"/>
-            <a:ext cx="8412480" cy="437449"/>
+            <a:off x="365760" y="3618813"/>
+            <a:ext cx="8412480" cy="231726"/>
           </a:xfrm>
           <a:prstGeom prst="rect">
             <a:avLst/>
@@ -23451,8 +23003,8 @@
         </p:nvSpPr>
         <p:spPr>
           <a:xfrm>
-            <a:off x="502920" y="3977640"/>
-            <a:ext cx="8229600" cy="418429"/>
+            <a:off x="502920" y="3655388"/>
+            <a:ext cx="8229600" cy="221651"/>
           </a:xfrm>
           <a:prstGeom prst="rect">
             <a:avLst/>
@@ -23490,8 +23042,8 @@
         </p:nvSpPr>
         <p:spPr>
           <a:xfrm>
-            <a:off x="365760" y="4416552"/>
-            <a:ext cx="8412480" cy="437449"/>
+            <a:off x="365760" y="4094301"/>
+            <a:ext cx="8412480" cy="231726"/>
           </a:xfrm>
           <a:prstGeom prst="rect">
             <a:avLst/>
@@ -23515,8 +23067,8 @@
         </p:nvSpPr>
         <p:spPr>
           <a:xfrm>
-            <a:off x="502920" y="4453128"/>
-            <a:ext cx="8229600" cy="418429"/>
+            <a:off x="502920" y="4130876"/>
+            <a:ext cx="8229600" cy="221651"/>
           </a:xfrm>
           <a:prstGeom prst="rect">
             <a:avLst/>
@@ -23554,8 +23106,8 @@
         </p:nvSpPr>
         <p:spPr>
           <a:xfrm>
-            <a:off x="365760" y="4892040"/>
-            <a:ext cx="8412480" cy="437449"/>
+            <a:off x="365760" y="4569789"/>
+            <a:ext cx="8412480" cy="231726"/>
           </a:xfrm>
           <a:prstGeom prst="rect">
             <a:avLst/>
@@ -23579,8 +23131,8 @@
         </p:nvSpPr>
         <p:spPr>
           <a:xfrm>
-            <a:off x="502920" y="4928616"/>
-            <a:ext cx="8229600" cy="418429"/>
+            <a:off x="502920" y="4606364"/>
+            <a:ext cx="8229600" cy="221651"/>
           </a:xfrm>
           <a:prstGeom prst="rect">
             <a:avLst/>
@@ -23618,8 +23170,8 @@
         </p:nvSpPr>
         <p:spPr>
           <a:xfrm>
-            <a:off x="365760" y="5367528"/>
-            <a:ext cx="8412480" cy="437449"/>
+            <a:off x="365760" y="4945530"/>
+            <a:ext cx="8412480" cy="231726"/>
           </a:xfrm>
           <a:prstGeom prst="rect">
             <a:avLst/>
@@ -23643,8 +23195,8 @@
         </p:nvSpPr>
         <p:spPr>
           <a:xfrm>
-            <a:off x="502920" y="5404104"/>
-            <a:ext cx="8229600" cy="418429"/>
+            <a:off x="502920" y="4982105"/>
+            <a:ext cx="8229600" cy="221651"/>
           </a:xfrm>
           <a:prstGeom prst="rect">
             <a:avLst/>
@@ -23682,8 +23234,8 @@
         </p:nvSpPr>
         <p:spPr>
           <a:xfrm>
-            <a:off x="365760" y="5843016"/>
-            <a:ext cx="8412480" cy="437449"/>
+            <a:off x="365760" y="5421018"/>
+            <a:ext cx="8412480" cy="231726"/>
           </a:xfrm>
           <a:prstGeom prst="rect">
             <a:avLst/>
@@ -23707,8 +23259,8 @@
         </p:nvSpPr>
         <p:spPr>
           <a:xfrm>
-            <a:off x="502920" y="5879592"/>
-            <a:ext cx="8229600" cy="418429"/>
+            <a:off x="502920" y="5457593"/>
+            <a:ext cx="8229600" cy="221651"/>
           </a:xfrm>
           <a:prstGeom prst="rect">
             <a:avLst/>
@@ -23735,70 +23287,6 @@
               <a:t>T[] array = (T[]) new Object[10];</a:t>
             </a:r>
             <a:endParaRPr lang="en-US" sz="1300" dirty="0"/>
-          </a:p>
-        </p:txBody>
-      </p:sp>
-      <p:sp>
-        <p:nvSpPr>
-          <p:cNvPr id="25" name="Shape 23"/>
-          <p:cNvSpPr/>
-          <p:nvPr/>
-        </p:nvSpPr>
-        <p:spPr>
-          <a:xfrm>
-            <a:off x="0" y="4919472"/>
-            <a:ext cx="9144000" cy="224028"/>
-          </a:xfrm>
-          <a:prstGeom prst="rect">
-            <a:avLst/>
-          </a:prstGeom>
-          <a:solidFill>
-            <a:srgbClr val="1A2B4A"/>
-          </a:solidFill>
-          <a:ln w="12700">
-            <a:solidFill>
-              <a:srgbClr val="1A2B4A"/>
-            </a:solidFill>
-            <a:prstDash val="solid"/>
-          </a:ln>
-        </p:spPr>
-      </p:sp>
-      <p:sp>
-        <p:nvSpPr>
-          <p:cNvPr id="26" name="Text 24"/>
-          <p:cNvSpPr/>
-          <p:nvPr/>
-        </p:nvSpPr>
-        <p:spPr>
-          <a:xfrm>
-            <a:off x="274320" y="4937760"/>
-            <a:ext cx="5486400" cy="182880"/>
-          </a:xfrm>
-          <a:prstGeom prst="rect">
-            <a:avLst/>
-          </a:prstGeom>
-          <a:noFill/>
-          <a:ln/>
-        </p:spPr>
-        <p:txBody>
-          <a:bodyPr wrap="square" lIns="0" tIns="0" rIns="0" bIns="0" rtlCol="0" anchor="ctr"/>
-          <a:lstStyle/>
-          <a:p>
-            <a:pPr marL="0" indent="0">
-              <a:buNone/>
-            </a:pPr>
-            <a:r>
-              <a:rPr lang="en-US" sz="900" dirty="0">
-                <a:solidFill>
-                  <a:srgbClr val="CBD5E1"/>
-                </a:solidFill>
-                <a:latin typeface="Calibri" pitchFamily="34" charset="0"/>
-                <a:ea typeface="Calibri" pitchFamily="34" charset="-122"/>
-                <a:cs typeface="Calibri" pitchFamily="34" charset="-120"/>
-              </a:rPr>
-              <a:t>Generics em Java</a:t>
-            </a:r>
-            <a:endParaRPr lang="en-US" sz="900" dirty="0"/>
           </a:p>
         </p:txBody>
       </p:sp>

</xml_diff>